<commit_message>
RAC 17장 수정 — restore spfile to 는 비파괴가 아니다
19장 측정 중 srvctl config database 의 Spfile 이 /tmp/spfile_ch17_test.ora
로 바뀌어 있는 것을 발견했다. 17장에서 이 명령을 "비파괴적" 이라고 서술한
것이 틀렸다.

대조 실험으로 원인을 특정
  복원 전                          Spfile: +DATA/RACDB/PARAMETERFILE/spfile.272...
  backup current controlfile 후    변화 없음
  restore spfile to '/tmp/...' 후  Spfile: /tmp/sp_probe.ora

실행 중인 인스턴스는 영향을 받지 않으므로(gv$parameter 는 여전히 +DATA)
그날은 정상으로 보이고 다음 srvctl 기동에서 문제가 드러난다.

수정 내용
- 본문에 17.7.4 "읽기 전용처럼 보이지만 아니다" 절과 @BP 추가, 요약 보강
- PPT 슬라이드 2장 추가 (부작용 / 원복 절차), 정리 슬라이드에 원복 항목
- 실습 07 에 [3-1] 오류 재현 절 추가, 헤더의 "비파괴" 표현 삭제,
  정리·기준선·점검 항목에 SPFILE 등록 경로 확인 추가
- 상-08 문항과 정답을 부작용 중심으로 교체

랩은 srvctl modify database -spfile 로 원복 완료.

Co-Authored-By: Claude Opus 5 (1M context) <noreply@anthropic.com>
</commit_message>
<xml_diff>
--- a/RAC/17장/17장_RAC백업과복구.pptx
+++ b/RAC/17장/17장_RAC백업과복구.pptx
@@ -47,6 +47,8 @@
     <p:sldId id="295" r:id="rId47"/>
     <p:sldId id="296" r:id="rId48"/>
     <p:sldId id="297" r:id="rId49"/>
+    <p:sldId id="298" r:id="rId50"/>
+    <p:sldId id="299" r:id="rId51"/>
   </p:sldIdLst>
   <p:sldSz cx="12191695" cy="6858000" type="screen4x3"/>
   <p:notesSz cx="6858000" cy="9144000"/>
@@ -1803,7 +1805,7 @@
           <a:lstStyle/>
           <a:p>
             <a:r>
-              <a:t>컨트롤파일을 실제로 지우는 실습은 위험하므로 이 방법으로 대신합니다. 실제 복구 절차와 같은 명령을 쓰면서 비파괴적이라는 것이 이 방법의 장점입니다. 복원한 파일에 인스턴스별 접두어가 온전히 있다는 것도 확인시키십시오. 12장에서 다룬 racdb1. 과 racdb2. 표기가 백업에도 그대로 보존되며, 이것이 복원 후 두 인스턴스가 각자의 설정을 되찾는 근거입니다. 4608 바이트라는 크기도 함께 확인하게 하십시오.</a:t>
+              <a:t>이 장에서 가장 조심해야 할 발견입니다. 이름에 restore 가 들어 있어 읽기 전용처럼 느껴지지만 복원 위치를 CRS 에 알려 주는 것까지가 이 명령의 동작입니다. 백업만 했을 때는 바뀌지 않았다는 대조가 원인을 특정해 줍니다. 실행 중인 인스턴스가 영향을 받지 않는다는 점이 오히려 위험합니다. 검증한 그날은 아무 문제가 없고 몇 주 뒤 계획 정지 후 재기동에서 드러나므로 진단하기 가장 어려운 종류의 사고입니다.</a:t>
             </a:r>
           </a:p>
         </p:txBody>
@@ -1873,7 +1875,7 @@
           <a:lstStyle/>
           <a:p>
             <a:r>
-              <a:t>이 랩에서는 실행하지 않고 절차만 익힙니다. RAC 특유의 주의점을 강조하십시오. 3 단계 전에 다른 인스턴스가 완전히 내려가 있어야 합니다. 하나만 살아 있어도 컨트롤파일을 잡고 있어 복원이 실패합니다. DBID 를 미리 기록해 두어야 한다는 점도 반드시 짚으십시오. 컨트롤파일이 없으면 데이터베이스가 자기 DBID 를 모릅니다. RMAN 접속 시 출력되는 값이며 운영 문서 첫 페이지에 적어 두는 것이 관례입니다.</a:t>
+              <a:t>컨트롤파일을 실제로 지우는 실습은 위험하므로 이 방법으로 대신합니다. 실제 복구 절차와 같은 명령을 쓰면서 비파괴적이라는 것이 이 방법의 장점입니다. 복원한 파일에 인스턴스별 접두어가 온전히 있다는 것도 확인시키십시오. 12장에서 다룬 racdb1. 과 racdb2. 표기가 백업에도 그대로 보존되며, 이것이 복원 후 두 인스턴스가 각자의 설정을 되찾는 근거입니다. 4608 바이트라는 크기도 함께 확인하게 하십시오.</a:t>
             </a:r>
           </a:p>
         </p:txBody>
@@ -1943,7 +1945,7 @@
           <a:lstStyle/>
           <a:p>
             <a:r>
-              <a:t>삭제 정책을 걸어 두지 않으면 언젠가 FRA 가 차고 데이터베이스가 멈춥니다. BACKED UP 1 TIMES TO DISK 가 출발점이라고 알려 주십시오. 그러면 FRA 가 찰 때 오라클이 백업된 아카이브를 자동으로 지웁니다. Data Guard 구성이라면 스탠바이 적용 여부까지 조건에 넣어야 합니다. 스탠바이에 아직 적용되지 않은 아카이브를 지우면 그쪽 복제가 끊깁니다. ADG 과정과 이어지는 지점입니다.</a:t>
+              <a:t>이 랩에서는 실행하지 않고 절차만 익힙니다. RAC 특유의 주의점을 강조하십시오. 3 단계 전에 다른 인스턴스가 완전히 내려가 있어야 합니다. 하나만 살아 있어도 컨트롤파일을 잡고 있어 복원이 실패합니다. DBID 를 미리 기록해 두어야 한다는 점도 반드시 짚으십시오. 컨트롤파일이 없으면 데이터베이스가 자기 DBID 를 모릅니다. RMAN 접속 시 출력되는 값이며 운영 문서 첫 페이지에 적어 두는 것이 관례입니다.</a:t>
             </a:r>
           </a:p>
         </p:txBody>
@@ -2013,7 +2015,7 @@
           <a:lstStyle/>
           <a:p>
             <a:r>
-              <a:t>세 번째가 이 장에서 얻은 항목입니다. 17.2 절에서 STATUS 가 INACTIVE 가 되어 ORA-16014 가 났고, 그 상태를 미리 잡아 줍니다. 네 번째와 다섯 번째가 RAC 특유입니다. 백업이 유효해도 한 노드에서만 유효하면 반쪽이고, 스레드마다 시퀀스가 독립적이므로 한 스레드만 끊길 수 있습니다. 전체를 뭉뚱그려 세면 그 끊김이 보이지 않으므로 반드시 thread# 로 group by 해야 합니다.</a:t>
+              <a:t>삭제 정책을 걸어 두지 않으면 언젠가 FRA 가 차고 데이터베이스가 멈춥니다. BACKED UP 1 TIMES TO DISK 가 출발점이라고 알려 주십시오. 그러면 FRA 가 찰 때 오라클이 백업된 아카이브를 자동으로 지웁니다. Data Guard 구성이라면 스탠바이 적용 여부까지 조건에 넣어야 합니다. 스탠바이에 아직 적용되지 않은 아카이브를 지우면 그쪽 복제가 끊깁니다. ADG 과정과 이어지는 지점입니다.</a:t>
             </a:r>
           </a:p>
         </p:txBody>
@@ -2153,7 +2155,7 @@
           <a:lstStyle/>
           <a:p>
             <a:r>
-              <a:t>이 장은 유일하게 기준선을 바꾸고 끝나는 장입니다. 왜 되돌리지 않는지 분명히 설명하십시오. 백업과 복구가 가능한 데이터베이스의 정상 구성이기 때문입니다. 대신 아카이브가 계속 쌓이므로 정기적으로 지우거나 삭제 정책을 걸어 두어야 한다는 조건이 붙습니다. 나머지는 모두 원래대로 돌려놓는다는 원칙은 그대로이며, 이 장에서도 실습 테이블스페이스와 백업을 모두 지웠습니다.</a:t>
+              <a:t>세 번째가 이 장에서 얻은 항목입니다. 17.2 절에서 STATUS 가 INACTIVE 가 되어 ORA-16014 가 났고, 그 상태를 미리 잡아 줍니다. 네 번째와 다섯 번째가 RAC 특유입니다. 백업이 유효해도 한 노드에서만 유효하면 반쪽이고, 스레드마다 시퀀스가 독립적이므로 한 스레드만 끊길 수 있습니다. 전체를 뭉뚱그려 세면 그 끊김이 보이지 않으므로 반드시 thread# 로 group by 해야 합니다.</a:t>
             </a:r>
           </a:p>
         </p:txBody>
@@ -2179,6 +2181,76 @@
 </file>
 
 <file path=ppt/notesSlides/notesSlide31.xml><?xml version="1.0" encoding="utf-8"?>
+<p:notes xmlns:a="http://schemas.openxmlformats.org/drawingml/2006/main" xmlns:p="http://schemas.openxmlformats.org/presentationml/2006/main" xmlns:r="http://schemas.openxmlformats.org/officeDocument/2006/relationships">
+  <p:cSld>
+    <p:spTree>
+      <p:nvGrpSpPr>
+        <p:cNvPr id="1" name=""/>
+        <p:cNvGrpSpPr/>
+        <p:nvPr/>
+      </p:nvGrpSpPr>
+      <p:grpSpPr>
+        <a:xfrm>
+          <a:off x="0" y="0"/>
+          <a:ext cx="0" cy="0"/>
+          <a:chOff x="0" y="0"/>
+          <a:chExt cx="0" cy="0"/>
+        </a:xfrm>
+      </p:grpSpPr>
+      <p:sp>
+        <p:nvSpPr>
+          <p:cNvPr id="2" name="Slide Image Placeholder 1"/>
+          <p:cNvSpPr>
+            <a:spLocks noGrp="1"/>
+          </p:cNvSpPr>
+          <p:nvPr>
+            <p:ph type="sldImg" idx="2"/>
+          </p:nvPr>
+        </p:nvSpPr>
+        <p:spPr/>
+      </p:sp>
+      <p:sp>
+        <p:nvSpPr>
+          <p:cNvPr id="3" name="Notes Placeholder 2"/>
+          <p:cNvSpPr>
+            <a:spLocks noGrp="1"/>
+          </p:cNvSpPr>
+          <p:nvPr>
+            <p:ph type="body" idx="3" sz="quarter"/>
+          </p:nvPr>
+        </p:nvSpPr>
+        <p:spPr/>
+        <p:txBody>
+          <a:bodyPr/>
+          <a:lstStyle/>
+          <a:p>
+            <a:r>
+              <a:t>이 장은 유일하게 기준선을 바꾸고 끝나는 장입니다. 왜 되돌리지 않는지 분명히 설명하십시오. 백업과 복구가 가능한 데이터베이스의 정상 구성이기 때문입니다. 대신 아카이브가 계속 쌓이므로 정기적으로 지우거나 삭제 정책을 걸어 두어야 한다는 조건이 붙습니다. 나머지는 모두 원래대로 돌려놓는다는 원칙은 그대로이며, 이 장에서도 실습 테이블스페이스와 백업을 모두 지웠습니다.</a:t>
+            </a:r>
+          </a:p>
+        </p:txBody>
+      </p:sp>
+      <p:sp>
+        <p:nvSpPr>
+          <p:cNvPr id="4" name="Slide Number Placeholder 3"/>
+          <p:cNvSpPr>
+            <a:spLocks noGrp="1"/>
+          </p:cNvSpPr>
+          <p:nvPr>
+            <p:ph type="sldNum" idx="5" sz="quarter"/>
+          </p:nvPr>
+        </p:nvSpPr>
+        <p:spPr/>
+      </p:sp>
+    </p:spTree>
+  </p:cSld>
+  <p:clrMapOvr>
+    <a:masterClrMapping/>
+  </p:clrMapOvr>
+</p:notes>
+</file>
+
+<file path=ppt/notesSlides/notesSlide32.xml><?xml version="1.0" encoding="utf-8"?>
 <p:notes xmlns:a="http://schemas.openxmlformats.org/drawingml/2006/main" xmlns:p="http://schemas.openxmlformats.org/presentationml/2006/main" xmlns:r="http://schemas.openxmlformats.org/officeDocument/2006/relationships">
   <p:cSld>
     <p:spTree>
@@ -12713,7 +12785,7 @@
                 </a:solidFill>
                 <a:latin typeface="맑은 고딕"/>
               </a:rPr>
-              <a:t>비파괴적으로 확인한다</a:t>
+              <a:t>자동 백업이 쓸 만한지 확인한다</a:t>
             </a:r>
           </a:p>
         </p:txBody>
@@ -12917,7 +12989,7 @@
                 </a:solidFill>
                 <a:latin typeface="맑은 고딕"/>
               </a:rPr>
-              <a:t>컨트롤파일을 모두 잃으면</a:t>
+              <a:t>그런데 읽기 전용이 아니다</a:t>
             </a:r>
           </a:p>
         </p:txBody>
@@ -12956,7 +13028,7 @@
                 </a:solidFill>
                 <a:latin typeface="맑은 고딕"/>
               </a:rPr>
-              <a:t>절차만 익힌다</a:t>
+              <a:t>이름에 속지 말 것</a:t>
             </a:r>
           </a:p>
         </p:txBody>
@@ -12995,7 +13067,7 @@
                 </a:solidFill>
                 <a:latin typeface="맑은 고딕"/>
               </a:rPr>
-              <a:t>•  1. srvctl stop database -o abort (정상 종료가 안 된다)</a:t>
+              <a:t>•  복원 전 Spfile: +DATA/RACDB/PARAMETERFILE/spfile.272...</a:t>
             </a:r>
           </a:p>
           <a:p>
@@ -13011,7 +13083,7 @@
                 </a:solidFill>
                 <a:latin typeface="맑은 고딕"/>
               </a:rPr>
-              <a:t>•  2. 한 노드에서 NOMOUNT (SPFILE 도 없으면 먼저 복원)</a:t>
+              <a:t>•  backup current controlfile 후에도 그대로 (백업은 안 바꾼다)</a:t>
             </a:r>
           </a:p>
           <a:p>
@@ -13027,7 +13099,7 @@
                 </a:solidFill>
                 <a:latin typeface="맑은 고딕"/>
               </a:rPr>
-              <a:t>•  3. set dbid 1240378513; restore controlfile from autobackup;</a:t>
+              <a:t>•  restore spfile to '/tmp/sp_probe.ora' 후 → Spfile: /tmp/sp_probe.ora</a:t>
             </a:r>
           </a:p>
           <a:p>
@@ -13043,7 +13115,7 @@
                 </a:solidFill>
                 <a:latin typeface="맑은 고딕"/>
               </a:rPr>
-              <a:t>•  4. alter database mount; recover database;</a:t>
+              <a:t>•  CRS 에 등록된 SPFILE 위치가 임시 경로로 바뀌었다</a:t>
             </a:r>
           </a:p>
           <a:p>
@@ -13059,7 +13131,7 @@
                 </a:solidFill>
                 <a:latin typeface="맑은 고딕"/>
               </a:rPr>
-              <a:t>•  5. alter database open resetlogs; → 6. 나머지 인스턴스 기동</a:t>
+              <a:t>•  실행 중인 인스턴스는 영향 없음 → 그날은 멀쩡해 보인다</a:t>
             </a:r>
           </a:p>
         </p:txBody>
@@ -13091,7 +13163,7 @@
         <p:spPr>
           <a:xfrm>
             <a:off x="0" y="0"/>
-            <a:ext cx="12191695" cy="6858000"/>
+            <a:ext cx="12191695" cy="1005840"/>
           </a:xfrm>
           <a:prstGeom prst="rect">
             <a:avLst/>
@@ -13134,8 +13206,8 @@
         </p:nvSpPr>
         <p:spPr>
           <a:xfrm>
-            <a:off x="822960" y="2011680"/>
-            <a:ext cx="10515600" cy="1097280"/>
+            <a:off x="548640" y="91440"/>
+            <a:ext cx="10972800" cy="777240"/>
           </a:xfrm>
           <a:prstGeom prst="rect">
             <a:avLst/>
@@ -13154,13 +13226,13 @@
               </a:spcAft>
             </a:pPr>
             <a:r>
-              <a:rPr sz="4000" b="1">
+              <a:rPr sz="2600" b="1">
                 <a:solidFill>
                   <a:srgbClr val="FFFFFF"/>
                 </a:solidFill>
                 <a:latin typeface="맑은 고딕"/>
               </a:rPr>
-              <a:t>17.8</a:t>
+              <a:t>반드시 되돌린다</a:t>
             </a:r>
           </a:p>
         </p:txBody>
@@ -13173,8 +13245,8 @@
         </p:nvSpPr>
         <p:spPr>
           <a:xfrm>
-            <a:off x="822960" y="3017520"/>
-            <a:ext cx="10515600" cy="914400"/>
+            <a:off x="640080" y="1078992"/>
+            <a:ext cx="10881360" cy="457200"/>
           </a:xfrm>
           <a:prstGeom prst="rect">
             <a:avLst/>
@@ -13193,71 +13265,27 @@
               </a:spcAft>
             </a:pPr>
             <a:r>
-              <a:rPr sz="2800" b="1">
-                <a:solidFill>
-                  <a:srgbClr val="FFFFFF"/>
-                </a:solidFill>
-                <a:latin typeface="맑은 고딕"/>
-              </a:rPr>
-              <a:t>정리와 운영 지침</a:t>
-            </a:r>
-          </a:p>
-        </p:txBody>
-      </p:sp>
-      <p:sp>
-        <p:nvSpPr>
-          <p:cNvPr id="5" name="Rectangle 4"/>
-          <p:cNvSpPr/>
-          <p:nvPr/>
-        </p:nvSpPr>
-        <p:spPr>
-          <a:xfrm>
-            <a:off x="822960" y="4114800"/>
-            <a:ext cx="5486400" cy="54864"/>
-          </a:xfrm>
-          <a:prstGeom prst="rect">
-            <a:avLst/>
-          </a:prstGeom>
-          <a:solidFill>
-            <a:srgbClr val="FFFFFF"/>
-          </a:solidFill>
-          <a:ln>
-            <a:noFill/>
-          </a:ln>
-          <a:effectLst/>
-        </p:spPr>
-        <p:style>
-          <a:lnRef idx="1">
-            <a:schemeClr val="accent1"/>
-          </a:lnRef>
-          <a:fillRef idx="3">
-            <a:schemeClr val="accent1"/>
-          </a:fillRef>
-          <a:effectRef idx="2">
-            <a:schemeClr val="accent1"/>
-          </a:effectRef>
-          <a:fontRef idx="minor">
-            <a:schemeClr val="lt1"/>
-          </a:fontRef>
-        </p:style>
-        <p:txBody>
-          <a:bodyPr rtlCol="0" anchor="ctr"/>
-          <a:lstStyle/>
-          <a:p>
-            <a:pPr algn="ctr"/>
-          </a:p>
-        </p:txBody>
-      </p:sp>
-      <p:sp>
-        <p:nvSpPr>
-          <p:cNvPr id="6" name="TextBox 5"/>
+              <a:rPr sz="1500" b="0">
+                <a:solidFill>
+                  <a:srgbClr val="5A6672"/>
+                </a:solidFill>
+                <a:latin typeface="맑은 고딕"/>
+              </a:rPr>
+              <a:t>복원 전에 값을 기록해 둘 것</a:t>
+            </a:r>
+          </a:p>
+        </p:txBody>
+      </p:sp>
+      <p:sp>
+        <p:nvSpPr>
+          <p:cNvPr id="5" name="TextBox 4"/>
           <p:cNvSpPr txBox="1"/>
           <p:nvPr/>
         </p:nvSpPr>
         <p:spPr>
           <a:xfrm>
-            <a:off x="822960" y="4297680"/>
-            <a:ext cx="10058400" cy="2011680"/>
+            <a:off x="640080" y="1737360"/>
+            <a:ext cx="10881360" cy="4754880"/>
           </a:xfrm>
           <a:prstGeom prst="rect">
             <a:avLst/>
@@ -13269,7 +13297,86 @@
             <a:spAutoFit/>
           </a:bodyPr>
           <a:lstStyle/>
-          <a:p/>
+          <a:p>
+            <a:pPr algn="l">
+              <a:spcAft>
+                <a:spcPts val="1000"/>
+              </a:spcAft>
+            </a:pPr>
+            <a:r>
+              <a:rPr sz="1700" b="0">
+                <a:solidFill>
+                  <a:srgbClr val="222222"/>
+                </a:solidFill>
+                <a:latin typeface="맑은 고딕"/>
+              </a:rPr>
+              <a:t>•  srvctl modify database -d racdb -spfile '+DATA/RACDB/PARAMETERFILE/spfile.272...'</a:t>
+            </a:r>
+          </a:p>
+          <a:p>
+            <a:pPr algn="l">
+              <a:spcAft>
+                <a:spcPts val="1000"/>
+              </a:spcAft>
+            </a:pPr>
+            <a:r>
+              <a:rPr sz="1700" b="0">
+                <a:solidFill>
+                  <a:srgbClr val="222222"/>
+                </a:solidFill>
+                <a:latin typeface="맑은 고딕"/>
+              </a:rPr>
+              <a:t>•  되돌릴 값을 알아야 하므로 복원 전에 먼저 기록한다</a:t>
+            </a:r>
+          </a:p>
+          <a:p>
+            <a:pPr algn="l">
+              <a:spcAft>
+                <a:spcPts val="1000"/>
+              </a:spcAft>
+            </a:pPr>
+            <a:r>
+              <a:rPr sz="1700" b="0">
+                <a:solidFill>
+                  <a:srgbClr val="222222"/>
+                </a:solidFill>
+                <a:latin typeface="맑은 고딕"/>
+              </a:rPr>
+              <a:t>•  더 안전한 검증 — list backup of spfile / of controlfile 로 존재만 확인</a:t>
+            </a:r>
+          </a:p>
+          <a:p>
+            <a:pPr algn="l">
+              <a:spcAft>
+                <a:spcPts val="1000"/>
+              </a:spcAft>
+            </a:pPr>
+            <a:r>
+              <a:rPr sz="1700" b="0">
+                <a:solidFill>
+                  <a:srgbClr val="222222"/>
+                </a:solidFill>
+                <a:latin typeface="맑은 고딕"/>
+              </a:rPr>
+              <a:t>•  실제 복구 상황이라면 이 동작이 맞다. 문제는 검증 목적일 때</a:t>
+            </a:r>
+          </a:p>
+          <a:p>
+            <a:pPr algn="l">
+              <a:spcAft>
+                <a:spcPts val="1000"/>
+              </a:spcAft>
+            </a:pPr>
+            <a:r>
+              <a:rPr sz="1700" b="0">
+                <a:solidFill>
+                  <a:srgbClr val="222222"/>
+                </a:solidFill>
+                <a:latin typeface="맑은 고딕"/>
+              </a:rPr>
+              <a:t>•  validate 계열은 읽기만 하고 restore 계열은 상태를 바꾼다</a:t>
+            </a:r>
+          </a:p>
         </p:txBody>
       </p:sp>
     </p:spTree>
@@ -13368,7 +13475,7 @@
                 </a:solidFill>
                 <a:latin typeface="맑은 고딕"/>
               </a:rPr>
-              <a:t>아카이브 관리 정책</a:t>
+              <a:t>컨트롤파일을 모두 잃으면</a:t>
             </a:r>
           </a:p>
         </p:txBody>
@@ -13407,7 +13514,7 @@
                 </a:solidFill>
                 <a:latin typeface="맑은 고딕"/>
               </a:rPr>
-              <a:t>정하지 않으면 FRA 가 찬다</a:t>
+              <a:t>절차만 익힌다</a:t>
             </a:r>
           </a:p>
         </p:txBody>
@@ -13446,7 +13553,7 @@
                 </a:solidFill>
                 <a:latin typeface="맑은 고딕"/>
               </a:rPr>
-              <a:t>•  NONE (기본값) — 자동으로 지우지 않는다</a:t>
+              <a:t>•  1. srvctl stop database -o abort (정상 종료가 안 된다)</a:t>
             </a:r>
           </a:p>
           <a:p>
@@ -13462,7 +13569,7 @@
                 </a:solidFill>
                 <a:latin typeface="맑은 고딕"/>
               </a:rPr>
-              <a:t>•  BACKED UP n TIMES TO DISK — 일반적인 선택</a:t>
+              <a:t>•  2. 한 노드에서 NOMOUNT (SPFILE 도 없으면 먼저 복원)</a:t>
             </a:r>
           </a:p>
           <a:p>
@@ -13478,7 +13585,7 @@
                 </a:solidFill>
                 <a:latin typeface="맑은 고딕"/>
               </a:rPr>
-              <a:t>•  APPLIED / SHIPPED ON ALL STANDBY — Data Guard 구성</a:t>
+              <a:t>•  3. set dbid 1240378513; restore controlfile from autobackup;</a:t>
             </a:r>
           </a:p>
           <a:p>
@@ -13494,7 +13601,7 @@
                 </a:solidFill>
                 <a:latin typeface="맑은 고딕"/>
               </a:rPr>
-              <a:t>•  정책은 데이터베이스 단위. 인스턴스별로 다르게 못 한다</a:t>
+              <a:t>•  4. alter database mount; recover database;</a:t>
             </a:r>
           </a:p>
           <a:p>
@@ -13510,7 +13617,7 @@
                 </a:solidFill>
                 <a:latin typeface="맑은 고딕"/>
               </a:rPr>
-              <a:t>•  이 랩은 NONE 이라 실습 후 수동으로 지웠다</a:t>
+              <a:t>•  5. alter database open resetlogs; → 6. 나머지 인스턴스 기동</a:t>
             </a:r>
           </a:p>
         </p:txBody>
@@ -13785,7 +13892,7 @@
         <p:spPr>
           <a:xfrm>
             <a:off x="0" y="0"/>
-            <a:ext cx="12191695" cy="1005840"/>
+            <a:ext cx="12191695" cy="6858000"/>
           </a:xfrm>
           <a:prstGeom prst="rect">
             <a:avLst/>
@@ -13828,8 +13935,8 @@
         </p:nvSpPr>
         <p:spPr>
           <a:xfrm>
-            <a:off x="548640" y="91440"/>
-            <a:ext cx="10972800" cy="777240"/>
+            <a:off x="822960" y="2011680"/>
+            <a:ext cx="10515600" cy="1097280"/>
           </a:xfrm>
           <a:prstGeom prst="rect">
             <a:avLst/>
@@ -13848,13 +13955,13 @@
               </a:spcAft>
             </a:pPr>
             <a:r>
-              <a:rPr sz="2600" b="1">
+              <a:rPr sz="4000" b="1">
                 <a:solidFill>
                   <a:srgbClr val="FFFFFF"/>
                 </a:solidFill>
                 <a:latin typeface="맑은 고딕"/>
               </a:rPr>
-              <a:t>이 장의 점검 항목</a:t>
+              <a:t>17.8</a:t>
             </a:r>
           </a:p>
         </p:txBody>
@@ -13867,8 +13974,8 @@
         </p:nvSpPr>
         <p:spPr>
           <a:xfrm>
-            <a:off x="640080" y="1078992"/>
-            <a:ext cx="10881360" cy="457200"/>
+            <a:off x="822960" y="3017520"/>
+            <a:ext cx="10515600" cy="914400"/>
           </a:xfrm>
           <a:prstGeom prst="rect">
             <a:avLst/>
@@ -13887,27 +13994,71 @@
               </a:spcAft>
             </a:pPr>
             <a:r>
-              <a:rPr sz="1500" b="0">
-                <a:solidFill>
-                  <a:srgbClr val="5A6672"/>
-                </a:solidFill>
-                <a:latin typeface="맑은 고딕"/>
-              </a:rPr>
-              <a:t>RAC 특유의 셋</a:t>
-            </a:r>
-          </a:p>
-        </p:txBody>
-      </p:sp>
-      <p:sp>
-        <p:nvSpPr>
-          <p:cNvPr id="5" name="TextBox 4"/>
+              <a:rPr sz="2800" b="1">
+                <a:solidFill>
+                  <a:srgbClr val="FFFFFF"/>
+                </a:solidFill>
+                <a:latin typeface="맑은 고딕"/>
+              </a:rPr>
+              <a:t>정리와 운영 지침</a:t>
+            </a:r>
+          </a:p>
+        </p:txBody>
+      </p:sp>
+      <p:sp>
+        <p:nvSpPr>
+          <p:cNvPr id="5" name="Rectangle 4"/>
+          <p:cNvSpPr/>
+          <p:nvPr/>
+        </p:nvSpPr>
+        <p:spPr>
+          <a:xfrm>
+            <a:off x="822960" y="4114800"/>
+            <a:ext cx="5486400" cy="54864"/>
+          </a:xfrm>
+          <a:prstGeom prst="rect">
+            <a:avLst/>
+          </a:prstGeom>
+          <a:solidFill>
+            <a:srgbClr val="FFFFFF"/>
+          </a:solidFill>
+          <a:ln>
+            <a:noFill/>
+          </a:ln>
+          <a:effectLst/>
+        </p:spPr>
+        <p:style>
+          <a:lnRef idx="1">
+            <a:schemeClr val="accent1"/>
+          </a:lnRef>
+          <a:fillRef idx="3">
+            <a:schemeClr val="accent1"/>
+          </a:fillRef>
+          <a:effectRef idx="2">
+            <a:schemeClr val="accent1"/>
+          </a:effectRef>
+          <a:fontRef idx="minor">
+            <a:schemeClr val="lt1"/>
+          </a:fontRef>
+        </p:style>
+        <p:txBody>
+          <a:bodyPr rtlCol="0" anchor="ctr"/>
+          <a:lstStyle/>
+          <a:p>
+            <a:pPr algn="ctr"/>
+          </a:p>
+        </p:txBody>
+      </p:sp>
+      <p:sp>
+        <p:nvSpPr>
+          <p:cNvPr id="6" name="TextBox 5"/>
           <p:cNvSpPr txBox="1"/>
           <p:nvPr/>
         </p:nvSpPr>
         <p:spPr>
           <a:xfrm>
-            <a:off x="640080" y="1737360"/>
-            <a:ext cx="10881360" cy="4754880"/>
+            <a:off x="822960" y="4297680"/>
+            <a:ext cx="10058400" cy="2011680"/>
           </a:xfrm>
           <a:prstGeom prst="rect">
             <a:avLst/>
@@ -13919,86 +14070,7 @@
             <a:spAutoFit/>
           </a:bodyPr>
           <a:lstStyle/>
-          <a:p>
-            <a:pPr algn="l">
-              <a:spcAft>
-                <a:spcPts val="1000"/>
-              </a:spcAft>
-            </a:pPr>
-            <a:r>
-              <a:rPr sz="1700" b="0">
-                <a:solidFill>
-                  <a:srgbClr val="222222"/>
-                </a:solidFill>
-                <a:latin typeface="맑은 고딕"/>
-              </a:rPr>
-              <a:t>•  매일 — 스레드별 아카이브 최근 생성 시각</a:t>
-            </a:r>
-          </a:p>
-          <a:p>
-            <a:pPr algn="l">
-              <a:spcAft>
-                <a:spcPts val="1000"/>
-              </a:spcAft>
-            </a:pPr>
-            <a:r>
-              <a:rPr sz="1700" b="0">
-                <a:solidFill>
-                  <a:srgbClr val="222222"/>
-                </a:solidFill>
-                <a:latin typeface="맑은 고딕"/>
-              </a:rPr>
-              <a:t>•  매일 — FRA 사용률 (space_used / space_limit)</a:t>
-            </a:r>
-          </a:p>
-          <a:p>
-            <a:pPr algn="l">
-              <a:spcAft>
-                <a:spcPts val="1000"/>
-              </a:spcAft>
-            </a:pPr>
-            <a:r>
-              <a:rPr sz="1700" b="0">
-                <a:solidFill>
-                  <a:srgbClr val="222222"/>
-                </a:solidFill>
-                <a:latin typeface="맑은 고딕"/>
-              </a:rPr>
-              <a:t>•  매일 — GV$ARCHIVE_DEST 의 STATUS 가 VALID 인가</a:t>
-            </a:r>
-          </a:p>
-          <a:p>
-            <a:pPr algn="l">
-              <a:spcAft>
-                <a:spcPts val="1000"/>
-              </a:spcAft>
-            </a:pPr>
-            <a:r>
-              <a:rPr sz="1700" b="0">
-                <a:solidFill>
-                  <a:srgbClr val="222222"/>
-                </a:solidFill>
-                <a:latin typeface="맑은 고딕"/>
-              </a:rPr>
-              <a:t>•  주간 — 다른 노드에서 restore database validate</a:t>
-            </a:r>
-          </a:p>
-          <a:p>
-            <a:pPr algn="l">
-              <a:spcAft>
-                <a:spcPts val="1000"/>
-              </a:spcAft>
-            </a:pPr>
-            <a:r>
-              <a:rPr sz="1700" b="0">
-                <a:solidFill>
-                  <a:srgbClr val="222222"/>
-                </a:solidFill>
-                <a:latin typeface="맑은 고딕"/>
-              </a:rPr>
-              <a:t>•  주간 — 스레드별 시퀀스 끊김 확인</a:t>
-            </a:r>
-          </a:p>
+          <a:p/>
         </p:txBody>
       </p:sp>
     </p:spTree>
@@ -14097,7 +14169,7 @@
                 </a:solidFill>
                 <a:latin typeface="맑은 고딕"/>
               </a:rPr>
-              <a:t>정리와 기준선</a:t>
+              <a:t>아카이브 관리 정책</a:t>
             </a:r>
           </a:p>
         </p:txBody>
@@ -14136,7 +14208,7 @@
                 </a:solidFill>
                 <a:latin typeface="맑은 고딕"/>
               </a:rPr>
-              <a:t>ARCHIVELOG 만 되돌리지 않는다</a:t>
+              <a:t>정하지 않으면 FRA 가 찬다</a:t>
             </a:r>
           </a:p>
         </p:txBody>
@@ -14175,7 +14247,7 @@
                 </a:solidFill>
                 <a:latin typeface="맑은 고딕"/>
               </a:rPr>
-              <a:t>•  실습 테이블스페이스 삭제, 백업·아카이브 삭제</a:t>
+              <a:t>•  NONE (기본값) — 자동으로 지우지 않는다</a:t>
             </a:r>
           </a:p>
           <a:p>
@@ -14191,7 +14263,7 @@
                 </a:solidFill>
                 <a:latin typeface="맑은 고딕"/>
               </a:rPr>
-              <a:t>•  FRA 825MB / 5개 파일 (컨트롤파일 1 + 리두 멤버 4)</a:t>
+              <a:t>•  BACKED UP n TIMES TO DISK — 일반적인 선택</a:t>
             </a:r>
           </a:p>
           <a:p>
@@ -14207,7 +14279,7 @@
                 </a:solidFill>
                 <a:latin typeface="맑은 고딕"/>
               </a:rPr>
-              <a:t>•  V$SPPARAMETER 로 log_archive_dest_1 미지정 확인</a:t>
+              <a:t>•  APPLIED / SHIPPED ON ALL STANDBY — Data Guard 구성</a:t>
             </a:r>
           </a:p>
           <a:p>
@@ -14223,7 +14295,7 @@
                 </a:solidFill>
                 <a:latin typeface="맑은 고딕"/>
               </a:rPr>
-              <a:t>•  CRS 자원 17개, 두 인스턴스 OPEN</a:t>
+              <a:t>•  정책은 데이터베이스 단위. 인스턴스별로 다르게 못 한다</a:t>
             </a:r>
           </a:p>
           <a:p>
@@ -14239,7 +14311,7 @@
                 </a:solidFill>
                 <a:latin typeface="맑은 고딕"/>
               </a:rPr>
-              <a:t>•  ARCHIVELOG 는 유지 — 이후 장에서도 이 상태를 전제</a:t>
+              <a:t>•  이 랩은 NONE 이라 실습 후 수동으로 지웠다</a:t>
             </a:r>
           </a:p>
         </p:txBody>
@@ -14253,6 +14325,508 @@
 </file>
 
 <file path=ppt/slides/slide42.xml><?xml version="1.0" encoding="utf-8"?>
+<p:sld xmlns:a="http://schemas.openxmlformats.org/drawingml/2006/main" xmlns:p="http://schemas.openxmlformats.org/presentationml/2006/main" xmlns:r="http://schemas.openxmlformats.org/officeDocument/2006/relationships">
+  <p:cSld>
+    <p:spTree>
+      <p:nvGrpSpPr>
+        <p:cNvPr id="1" name=""/>
+        <p:cNvGrpSpPr/>
+        <p:nvPr/>
+      </p:nvGrpSpPr>
+      <p:grpSpPr/>
+      <p:sp>
+        <p:nvSpPr>
+          <p:cNvPr id="2" name="Rectangle 1"/>
+          <p:cNvSpPr/>
+          <p:nvPr/>
+        </p:nvSpPr>
+        <p:spPr>
+          <a:xfrm>
+            <a:off x="0" y="0"/>
+            <a:ext cx="12191695" cy="1005840"/>
+          </a:xfrm>
+          <a:prstGeom prst="rect">
+            <a:avLst/>
+          </a:prstGeom>
+          <a:solidFill>
+            <a:srgbClr val="C0392B"/>
+          </a:solidFill>
+          <a:ln>
+            <a:noFill/>
+          </a:ln>
+          <a:effectLst/>
+        </p:spPr>
+        <p:style>
+          <a:lnRef idx="1">
+            <a:schemeClr val="accent1"/>
+          </a:lnRef>
+          <a:fillRef idx="3">
+            <a:schemeClr val="accent1"/>
+          </a:fillRef>
+          <a:effectRef idx="2">
+            <a:schemeClr val="accent1"/>
+          </a:effectRef>
+          <a:fontRef idx="minor">
+            <a:schemeClr val="lt1"/>
+          </a:fontRef>
+        </p:style>
+        <p:txBody>
+          <a:bodyPr rtlCol="0" anchor="ctr"/>
+          <a:lstStyle/>
+          <a:p>
+            <a:pPr algn="ctr"/>
+          </a:p>
+        </p:txBody>
+      </p:sp>
+      <p:sp>
+        <p:nvSpPr>
+          <p:cNvPr id="3" name="TextBox 2"/>
+          <p:cNvSpPr txBox="1"/>
+          <p:nvPr/>
+        </p:nvSpPr>
+        <p:spPr>
+          <a:xfrm>
+            <a:off x="548640" y="91440"/>
+            <a:ext cx="10972800" cy="777240"/>
+          </a:xfrm>
+          <a:prstGeom prst="rect">
+            <a:avLst/>
+          </a:prstGeom>
+          <a:noFill/>
+        </p:spPr>
+        <p:txBody>
+          <a:bodyPr wrap="square">
+            <a:spAutoFit/>
+          </a:bodyPr>
+          <a:lstStyle/>
+          <a:p>
+            <a:pPr algn="l">
+              <a:spcAft>
+                <a:spcPts val="600"/>
+              </a:spcAft>
+            </a:pPr>
+            <a:r>
+              <a:rPr sz="2600" b="1">
+                <a:solidFill>
+                  <a:srgbClr val="FFFFFF"/>
+                </a:solidFill>
+                <a:latin typeface="맑은 고딕"/>
+              </a:rPr>
+              <a:t>이 장의 점검 항목</a:t>
+            </a:r>
+          </a:p>
+        </p:txBody>
+      </p:sp>
+      <p:sp>
+        <p:nvSpPr>
+          <p:cNvPr id="4" name="TextBox 3"/>
+          <p:cNvSpPr txBox="1"/>
+          <p:nvPr/>
+        </p:nvSpPr>
+        <p:spPr>
+          <a:xfrm>
+            <a:off x="640080" y="1078992"/>
+            <a:ext cx="10881360" cy="457200"/>
+          </a:xfrm>
+          <a:prstGeom prst="rect">
+            <a:avLst/>
+          </a:prstGeom>
+          <a:noFill/>
+        </p:spPr>
+        <p:txBody>
+          <a:bodyPr wrap="square">
+            <a:spAutoFit/>
+          </a:bodyPr>
+          <a:lstStyle/>
+          <a:p>
+            <a:pPr algn="l">
+              <a:spcAft>
+                <a:spcPts val="600"/>
+              </a:spcAft>
+            </a:pPr>
+            <a:r>
+              <a:rPr sz="1500" b="0">
+                <a:solidFill>
+                  <a:srgbClr val="5A6672"/>
+                </a:solidFill>
+                <a:latin typeface="맑은 고딕"/>
+              </a:rPr>
+              <a:t>RAC 특유의 셋</a:t>
+            </a:r>
+          </a:p>
+        </p:txBody>
+      </p:sp>
+      <p:sp>
+        <p:nvSpPr>
+          <p:cNvPr id="5" name="TextBox 4"/>
+          <p:cNvSpPr txBox="1"/>
+          <p:nvPr/>
+        </p:nvSpPr>
+        <p:spPr>
+          <a:xfrm>
+            <a:off x="640080" y="1737360"/>
+            <a:ext cx="10881360" cy="4754880"/>
+          </a:xfrm>
+          <a:prstGeom prst="rect">
+            <a:avLst/>
+          </a:prstGeom>
+          <a:noFill/>
+        </p:spPr>
+        <p:txBody>
+          <a:bodyPr wrap="square">
+            <a:spAutoFit/>
+          </a:bodyPr>
+          <a:lstStyle/>
+          <a:p>
+            <a:pPr algn="l">
+              <a:spcAft>
+                <a:spcPts val="1000"/>
+              </a:spcAft>
+            </a:pPr>
+            <a:r>
+              <a:rPr sz="1700" b="0">
+                <a:solidFill>
+                  <a:srgbClr val="222222"/>
+                </a:solidFill>
+                <a:latin typeface="맑은 고딕"/>
+              </a:rPr>
+              <a:t>•  매일 — 스레드별 아카이브 최근 생성 시각</a:t>
+            </a:r>
+          </a:p>
+          <a:p>
+            <a:pPr algn="l">
+              <a:spcAft>
+                <a:spcPts val="1000"/>
+              </a:spcAft>
+            </a:pPr>
+            <a:r>
+              <a:rPr sz="1700" b="0">
+                <a:solidFill>
+                  <a:srgbClr val="222222"/>
+                </a:solidFill>
+                <a:latin typeface="맑은 고딕"/>
+              </a:rPr>
+              <a:t>•  매일 — FRA 사용률 (space_used / space_limit)</a:t>
+            </a:r>
+          </a:p>
+          <a:p>
+            <a:pPr algn="l">
+              <a:spcAft>
+                <a:spcPts val="1000"/>
+              </a:spcAft>
+            </a:pPr>
+            <a:r>
+              <a:rPr sz="1700" b="0">
+                <a:solidFill>
+                  <a:srgbClr val="222222"/>
+                </a:solidFill>
+                <a:latin typeface="맑은 고딕"/>
+              </a:rPr>
+              <a:t>•  매일 — GV$ARCHIVE_DEST 의 STATUS 가 VALID 인가</a:t>
+            </a:r>
+          </a:p>
+          <a:p>
+            <a:pPr algn="l">
+              <a:spcAft>
+                <a:spcPts val="1000"/>
+              </a:spcAft>
+            </a:pPr>
+            <a:r>
+              <a:rPr sz="1700" b="0">
+                <a:solidFill>
+                  <a:srgbClr val="222222"/>
+                </a:solidFill>
+                <a:latin typeface="맑은 고딕"/>
+              </a:rPr>
+              <a:t>•  주간 — 다른 노드에서 restore database validate</a:t>
+            </a:r>
+          </a:p>
+          <a:p>
+            <a:pPr algn="l">
+              <a:spcAft>
+                <a:spcPts val="1000"/>
+              </a:spcAft>
+            </a:pPr>
+            <a:r>
+              <a:rPr sz="1700" b="0">
+                <a:solidFill>
+                  <a:srgbClr val="222222"/>
+                </a:solidFill>
+                <a:latin typeface="맑은 고딕"/>
+              </a:rPr>
+              <a:t>•  주간 — 스레드별 시퀀스 끊김 확인</a:t>
+            </a:r>
+          </a:p>
+        </p:txBody>
+      </p:sp>
+    </p:spTree>
+  </p:cSld>
+  <p:clrMapOvr>
+    <a:masterClrMapping/>
+  </p:clrMapOvr>
+</p:sld>
+</file>
+
+<file path=ppt/slides/slide43.xml><?xml version="1.0" encoding="utf-8"?>
+<p:sld xmlns:a="http://schemas.openxmlformats.org/drawingml/2006/main" xmlns:p="http://schemas.openxmlformats.org/presentationml/2006/main" xmlns:r="http://schemas.openxmlformats.org/officeDocument/2006/relationships">
+  <p:cSld>
+    <p:spTree>
+      <p:nvGrpSpPr>
+        <p:cNvPr id="1" name=""/>
+        <p:cNvGrpSpPr/>
+        <p:nvPr/>
+      </p:nvGrpSpPr>
+      <p:grpSpPr/>
+      <p:sp>
+        <p:nvSpPr>
+          <p:cNvPr id="2" name="Rectangle 1"/>
+          <p:cNvSpPr/>
+          <p:nvPr/>
+        </p:nvSpPr>
+        <p:spPr>
+          <a:xfrm>
+            <a:off x="0" y="0"/>
+            <a:ext cx="12191695" cy="1005840"/>
+          </a:xfrm>
+          <a:prstGeom prst="rect">
+            <a:avLst/>
+          </a:prstGeom>
+          <a:solidFill>
+            <a:srgbClr val="C0392B"/>
+          </a:solidFill>
+          <a:ln>
+            <a:noFill/>
+          </a:ln>
+          <a:effectLst/>
+        </p:spPr>
+        <p:style>
+          <a:lnRef idx="1">
+            <a:schemeClr val="accent1"/>
+          </a:lnRef>
+          <a:fillRef idx="3">
+            <a:schemeClr val="accent1"/>
+          </a:fillRef>
+          <a:effectRef idx="2">
+            <a:schemeClr val="accent1"/>
+          </a:effectRef>
+          <a:fontRef idx="minor">
+            <a:schemeClr val="lt1"/>
+          </a:fontRef>
+        </p:style>
+        <p:txBody>
+          <a:bodyPr rtlCol="0" anchor="ctr"/>
+          <a:lstStyle/>
+          <a:p>
+            <a:pPr algn="ctr"/>
+          </a:p>
+        </p:txBody>
+      </p:sp>
+      <p:sp>
+        <p:nvSpPr>
+          <p:cNvPr id="3" name="TextBox 2"/>
+          <p:cNvSpPr txBox="1"/>
+          <p:nvPr/>
+        </p:nvSpPr>
+        <p:spPr>
+          <a:xfrm>
+            <a:off x="548640" y="91440"/>
+            <a:ext cx="10972800" cy="777240"/>
+          </a:xfrm>
+          <a:prstGeom prst="rect">
+            <a:avLst/>
+          </a:prstGeom>
+          <a:noFill/>
+        </p:spPr>
+        <p:txBody>
+          <a:bodyPr wrap="square">
+            <a:spAutoFit/>
+          </a:bodyPr>
+          <a:lstStyle/>
+          <a:p>
+            <a:pPr algn="l">
+              <a:spcAft>
+                <a:spcPts val="600"/>
+              </a:spcAft>
+            </a:pPr>
+            <a:r>
+              <a:rPr sz="2600" b="1">
+                <a:solidFill>
+                  <a:srgbClr val="FFFFFF"/>
+                </a:solidFill>
+                <a:latin typeface="맑은 고딕"/>
+              </a:rPr>
+              <a:t>정리와 기준선</a:t>
+            </a:r>
+          </a:p>
+        </p:txBody>
+      </p:sp>
+      <p:sp>
+        <p:nvSpPr>
+          <p:cNvPr id="4" name="TextBox 3"/>
+          <p:cNvSpPr txBox="1"/>
+          <p:nvPr/>
+        </p:nvSpPr>
+        <p:spPr>
+          <a:xfrm>
+            <a:off x="640080" y="1078992"/>
+            <a:ext cx="10881360" cy="457200"/>
+          </a:xfrm>
+          <a:prstGeom prst="rect">
+            <a:avLst/>
+          </a:prstGeom>
+          <a:noFill/>
+        </p:spPr>
+        <p:txBody>
+          <a:bodyPr wrap="square">
+            <a:spAutoFit/>
+          </a:bodyPr>
+          <a:lstStyle/>
+          <a:p>
+            <a:pPr algn="l">
+              <a:spcAft>
+                <a:spcPts val="600"/>
+              </a:spcAft>
+            </a:pPr>
+            <a:r>
+              <a:rPr sz="1500" b="0">
+                <a:solidFill>
+                  <a:srgbClr val="5A6672"/>
+                </a:solidFill>
+                <a:latin typeface="맑은 고딕"/>
+              </a:rPr>
+              <a:t>ARCHIVELOG 만 되돌리지 않는다</a:t>
+            </a:r>
+          </a:p>
+        </p:txBody>
+      </p:sp>
+      <p:sp>
+        <p:nvSpPr>
+          <p:cNvPr id="5" name="TextBox 4"/>
+          <p:cNvSpPr txBox="1"/>
+          <p:nvPr/>
+        </p:nvSpPr>
+        <p:spPr>
+          <a:xfrm>
+            <a:off x="640080" y="1737360"/>
+            <a:ext cx="10881360" cy="4754880"/>
+          </a:xfrm>
+          <a:prstGeom prst="rect">
+            <a:avLst/>
+          </a:prstGeom>
+          <a:noFill/>
+        </p:spPr>
+        <p:txBody>
+          <a:bodyPr wrap="square">
+            <a:spAutoFit/>
+          </a:bodyPr>
+          <a:lstStyle/>
+          <a:p>
+            <a:pPr algn="l">
+              <a:spcAft>
+                <a:spcPts val="1000"/>
+              </a:spcAft>
+            </a:pPr>
+            <a:r>
+              <a:rPr sz="1700" b="0">
+                <a:solidFill>
+                  <a:srgbClr val="222222"/>
+                </a:solidFill>
+                <a:latin typeface="맑은 고딕"/>
+              </a:rPr>
+              <a:t>•  실습 테이블스페이스 삭제, 백업·아카이브 삭제</a:t>
+            </a:r>
+          </a:p>
+          <a:p>
+            <a:pPr algn="l">
+              <a:spcAft>
+                <a:spcPts val="1000"/>
+              </a:spcAft>
+            </a:pPr>
+            <a:r>
+              <a:rPr sz="1700" b="0">
+                <a:solidFill>
+                  <a:srgbClr val="222222"/>
+                </a:solidFill>
+                <a:latin typeface="맑은 고딕"/>
+              </a:rPr>
+              <a:t>•  SPFILE 등록 정보 원복 확인 (17.7.4 절의 부작용)</a:t>
+            </a:r>
+          </a:p>
+          <a:p>
+            <a:pPr algn="l">
+              <a:spcAft>
+                <a:spcPts val="1000"/>
+              </a:spcAft>
+            </a:pPr>
+            <a:r>
+              <a:rPr sz="1700" b="0">
+                <a:solidFill>
+                  <a:srgbClr val="222222"/>
+                </a:solidFill>
+                <a:latin typeface="맑은 고딕"/>
+              </a:rPr>
+              <a:t>•  FRA 825MB / 5개 파일 (컨트롤파일 1 + 리두 멤버 4)</a:t>
+            </a:r>
+          </a:p>
+          <a:p>
+            <a:pPr algn="l">
+              <a:spcAft>
+                <a:spcPts val="1000"/>
+              </a:spcAft>
+            </a:pPr>
+            <a:r>
+              <a:rPr sz="1700" b="0">
+                <a:solidFill>
+                  <a:srgbClr val="222222"/>
+                </a:solidFill>
+                <a:latin typeface="맑은 고딕"/>
+              </a:rPr>
+              <a:t>•  V$SPPARAMETER 로 log_archive_dest_1 미지정 확인</a:t>
+            </a:r>
+          </a:p>
+          <a:p>
+            <a:pPr algn="l">
+              <a:spcAft>
+                <a:spcPts val="1000"/>
+              </a:spcAft>
+            </a:pPr>
+            <a:r>
+              <a:rPr sz="1700" b="0">
+                <a:solidFill>
+                  <a:srgbClr val="222222"/>
+                </a:solidFill>
+                <a:latin typeface="맑은 고딕"/>
+              </a:rPr>
+              <a:t>•  CRS 자원 17개, 두 인스턴스 OPEN</a:t>
+            </a:r>
+          </a:p>
+          <a:p>
+            <a:pPr algn="l">
+              <a:spcAft>
+                <a:spcPts val="1000"/>
+              </a:spcAft>
+            </a:pPr>
+            <a:r>
+              <a:rPr sz="1700" b="0">
+                <a:solidFill>
+                  <a:srgbClr val="222222"/>
+                </a:solidFill>
+                <a:latin typeface="맑은 고딕"/>
+              </a:rPr>
+              <a:t>•  ARCHIVELOG 는 유지 — 이후 장에서도 이 상태를 전제</a:t>
+            </a:r>
+          </a:p>
+        </p:txBody>
+      </p:sp>
+    </p:spTree>
+  </p:cSld>
+  <p:clrMapOvr>
+    <a:masterClrMapping/>
+  </p:clrMapOvr>
+</p:sld>
+</file>
+
+<file path=ppt/slides/slide44.xml><?xml version="1.0" encoding="utf-8"?>
 <p:sld xmlns:a="http://schemas.openxmlformats.org/drawingml/2006/main" xmlns:p="http://schemas.openxmlformats.org/presentationml/2006/main" xmlns:r="http://schemas.openxmlformats.org/officeDocument/2006/relationships">
   <p:cSld>
     <p:spTree>

</xml_diff>